<commit_message>
Complete SQL question logic and verification
Co-authored-by: Copilot <223556219+Copilot@users.noreply.github.com>
</commit_message>
<xml_diff>
--- a/presentation/PeopleOps_HR_Pipeline_Results.pptx
+++ b/presentation/PeopleOps_HR_Pipeline_Results.pptx
@@ -7277,7 +7277,7 @@
               </a:defRPr>
             </a:pPr>
             <a:r>
-              <a:t>126</a:t>
+              <a:t>21</a:t>
             </a:r>
           </a:p>
         </p:txBody>
@@ -7313,7 +7313,7 @@
               </a:defRPr>
             </a:pPr>
             <a:r>
-              <a:t>Non-zero payroll rows after separation month</a:t>
+              <a:t>Earnings in months after separation</a:t>
             </a:r>
           </a:p>
         </p:txBody>
@@ -7421,7 +7421,7 @@
               </a:defRPr>
             </a:pPr>
             <a:r>
-              <a:t>Additional check: 20 annual-leave flags; 13 paid employee-months with zero Present days.</a:t>
+              <a:t>Additional check: 20 annual-leave flags; 59 paid employee-months with zero Present days.</a:t>
             </a:r>
           </a:p>
         </p:txBody>

</xml_diff>